<commit_message>
Add OpenRouter + LangChain AI layer and live demo materials
- LangChain LCEL chain (prompt -> ChatOpenAI on OpenRouter -> parser)
  with attribution headers, model fallbacks, timeout, retries and cache
- Numeric-grounding guardrail retained; graceful extractive fallback
- /api/ai/status endpoint and AI mode badge in the traveller UI
- .env.example, dotenv loading, run.sh pre-flight
- 5 new tests (23 total) covering offline mode, LCEL path, guardrail,
  PII redaction and status endpoint
- 17-slide live demo deck with speaker notes and timed runbook
- README updated with AI stack and demo material links
</commit_message>
<xml_diff>
--- a/presentation/YatraSetu_AI_Pitch.pptx
+++ b/presentation/YatraSetu_AI_Pitch.pptx
@@ -3657,6 +3657,10 @@
             <a:prstDash val="solid"/>
           </a:ln>
         </p:spPr>
+        <p:txBody>
+          <a:bodyPr/>
+          <a:p/>
+        </p:txBody>
       </p:sp>
       <p:sp>
         <p:nvSpPr>
@@ -3723,6 +3727,10 @@
             <a:prstDash val="solid"/>
           </a:ln>
         </p:spPr>
+        <p:txBody>
+          <a:bodyPr/>
+          <a:p/>
+        </p:txBody>
       </p:sp>
       <p:sp>
         <p:nvSpPr>
@@ -3789,6 +3797,10 @@
             <a:prstDash val="solid"/>
           </a:ln>
         </p:spPr>
+        <p:txBody>
+          <a:bodyPr/>
+          <a:p/>
+        </p:txBody>
       </p:sp>
       <p:sp>
         <p:nvSpPr>
@@ -3855,6 +3867,10 @@
             <a:prstDash val="solid"/>
           </a:ln>
         </p:spPr>
+        <p:txBody>
+          <a:bodyPr/>
+          <a:p/>
+        </p:txBody>
       </p:sp>
       <p:sp>
         <p:nvSpPr>
@@ -3889,7 +3905,7 @@
                 <a:ea typeface="Calibri" pitchFamily="34" charset="-122"/>
                 <a:cs typeface="Calibri" pitchFamily="34" charset="-120"/>
               </a:rPr>
-              <a:t>Retrieval-augmented answers · Intent model · Gradient-boosted forecaster · Risk scoring · Bhashini for Indian languages</a:t>
+              <a:t>LangChain RAG on OpenRouter · Intent model · Gradient-boosted forecaster · Risk scoring · Bhashini for Indian languages</a:t>
             </a:r>
             <a:endParaRPr lang="en-US" sz="1350" dirty="0"/>
           </a:p>
@@ -3921,6 +3937,10 @@
             <a:prstDash val="solid"/>
           </a:ln>
         </p:spPr>
+        <p:txBody>
+          <a:bodyPr/>
+          <a:p/>
+        </p:txBody>
       </p:sp>
       <p:sp>
         <p:nvSpPr>
@@ -3987,6 +4007,10 @@
             <a:prstDash val="solid"/>
           </a:ln>
         </p:spPr>
+        <p:txBody>
+          <a:bodyPr/>
+          <a:p/>
+        </p:txBody>
       </p:sp>
       <p:sp>
         <p:nvSpPr>

</xml_diff>

<commit_message>
Update pitch deck metrics and stack line for OpenRouter + LangChain
</commit_message>
<xml_diff>
--- a/presentation/YatraSetu_AI_Pitch.pptx
+++ b/presentation/YatraSetu_AI_Pitch.pptx
@@ -4459,6 +4459,10 @@
             <a:prstDash val="solid"/>
           </a:ln>
         </p:spPr>
+        <p:txBody>
+          <a:bodyPr/>
+          <a:p/>
+        </p:txBody>
       </p:sp>
       <p:sp>
         <p:nvSpPr>
@@ -4493,7 +4497,7 @@
                 <a:ea typeface="Cambria" pitchFamily="34" charset="-122"/>
                 <a:cs typeface="Cambria" pitchFamily="34" charset="-120"/>
               </a:rPr>
-              <a:t>18 / 18</a:t>
+              <a:t>23 / 23</a:t>
             </a:r>
             <a:endParaRPr lang="en-US" sz="2800" dirty="0"/>
           </a:p>
@@ -4564,6 +4568,10 @@
             <a:prstDash val="solid"/>
           </a:ln>
         </p:spPr>
+        <p:txBody>
+          <a:bodyPr/>
+          <a:p/>
+        </p:txBody>
       </p:sp>
       <p:sp>
         <p:nvSpPr>
@@ -4598,7 +4606,7 @@
                 <a:ea typeface="Cambria" pitchFamily="34" charset="-122"/>
                 <a:cs typeface="Cambria" pitchFamily="34" charset="-120"/>
               </a:rPr>
-              <a:t>~4 ms</a:t>
+              <a:t>~1.3 ms</a:t>
             </a:r>
             <a:endParaRPr lang="en-US" sz="2800" dirty="0"/>
           </a:p>
@@ -4669,6 +4677,10 @@
             <a:prstDash val="solid"/>
           </a:ln>
         </p:spPr>
+        <p:txBody>
+          <a:bodyPr/>
+          <a:p/>
+        </p:txBody>
       </p:sp>
       <p:sp>
         <p:nvSpPr>

</xml_diff>